<commit_message>
Rebrand tagline to "Build with the right people"; make server PORT configurable
- Update motto in app header + auth screen (App.tsx, AuthCard.tsx)
- server.ts: PORT now reads from env, falls back to 3000
- Rebuild both capstone presentation decks with the new motto

Co-Authored-By: Claude Opus 4.8 <noreply@anthropic.com>
</commit_message>
<xml_diff>
--- a/Zetwork Capstone Presentation.pptx
+++ b/Zetwork Capstone Presentation.pptx
@@ -3351,7 +3351,7 @@
                 </a:solidFill>
                 <a:latin typeface="Consolas"/>
               </a:rPr>
-              <a:t>POWERING TECH TEAM MATCHING</a:t>
+              <a:t>BUILD WITH THE RIGHT PEOPLE</a:t>
             </a:r>
           </a:p>
         </p:txBody>
@@ -5458,7 +5458,7 @@
                 </a:solidFill>
                 <a:latin typeface="Consolas"/>
               </a:rPr>
-              <a:t>ZETWORK  ·  POWERING TECH TEAM MATCHING</a:t>
+              <a:t>ZETWORK  ·  BUILD WITH THE RIGHT PEOPLE</a:t>
             </a:r>
           </a:p>
         </p:txBody>

</xml_diff>